<commit_message>
engine and ai improvization was done
</commit_message>
<xml_diff>
--- a/temp_test/input.pptx
+++ b/temp_test/input.pptx
@@ -3164,6 +3164,16 @@
           <a:p>
             <a:r>
               <a:t>Module Lead: Sarah Connor</a:t>
+            </a:r>
+          </a:p>
+          <a:p>
+            <a:r>
+              <a:t>Academic Year 2025-26</a:t>
+            </a:r>
+          </a:p>
+          <a:p>
+            <a:r>
+              <a:t>Module Code: BM414</a:t>
             </a:r>
           </a:p>
           <a:p>

</xml_diff>